<commit_message>
Haal prijs per afspraak uit de standaardpilot en benoem de inrichting
Co-Authored-By: Claude Fable 5 <noreply@anthropic.com>
Claude-Session: https://claude.ai/code/session_0141FN3f3hHkYQHTyvTJJGrw
</commit_message>
<xml_diff>
--- a/output/LINK. standaardpilot.pptx
+++ b/output/LINK. standaardpilot.pptx
@@ -3999,7 +3999,7 @@
                 <a:ea typeface="Arial" pitchFamily="34" charset="-122"/>
                 <a:cs typeface="Arial" pitchFamily="34" charset="-120"/>
               </a:rPr>
-              <a:t>Twaalf weken dagelijks bellen en mailen</a:t>
+              <a:t>Volledige inrichting van belsysteem en nummer</a:t>
             </a:r>
             <a:endParaRPr lang="en-US" sz="900" dirty="0"/>
           </a:p>
@@ -4062,7 +4062,7 @@
                 <a:ea typeface="Arial" pitchFamily="34" charset="-122"/>
                 <a:cs typeface="Arial" pitchFamily="34" charset="-120"/>
               </a:rPr>
-              <a:t>Rapportage elke week, evaluatie om de week</a:t>
+              <a:t>Twaalf weken dagelijks bellen en mailen</a:t>
             </a:r>
             <a:endParaRPr lang="en-US" sz="900" dirty="0"/>
           </a:p>
@@ -4125,7 +4125,7 @@
                 <a:ea typeface="Arial" pitchFamily="34" charset="-122"/>
                 <a:cs typeface="Arial" pitchFamily="34" charset="-120"/>
               </a:rPr>
-              <a:t>Tien gekwalificeerde afspraken, € 495 per afspraak</a:t>
+              <a:t>Rapportage elke week, evaluatie om de week</a:t>
             </a:r>
             <a:endParaRPr lang="en-US" sz="900" dirty="0"/>
           </a:p>
@@ -4188,7 +4188,7 @@
                 <a:ea typeface="Arial" pitchFamily="34" charset="-122"/>
                 <a:cs typeface="Arial" pitchFamily="34" charset="-120"/>
               </a:rPr>
-              <a:t>Eindrapport met marktinzicht en advies</a:t>
+              <a:t>Tien gekwalificeerde afspraken</a:t>
             </a:r>
             <a:endParaRPr lang="en-US" sz="900" dirty="0"/>
           </a:p>

</xml_diff>